<commit_message>
chore: regenerate vendored artifacts and previews from current builders
The committed Office files and their preview PNGs predated the copy
waves: the binaries carried 8 instances of the removed screening term
and 49 em-dashes, and the in-app preview rail rendered those stale
pages. Rebuilt all three artifacts and re-rendered every preview from
the current builders (all clean). The render script's module hooks now
attach the json import attribute plain node requires, it had been
broken since the model engine gained its static data import.

Co-Authored-By: Claude Fable 5 <noreply@anthropic.com>
</commit_message>
<xml_diff>
--- a/public/artifacts/jahez-board-deck.pptx
+++ b/public/artifacts/jahez-board-deck.pptx
@@ -1356,7 +1356,7 @@
                 <a:ea typeface="Arial" pitchFamily="34" charset="-122"/>
                 <a:cs typeface="Arial" pitchFamily="34" charset="-120"/>
               </a:rPr>
-              <a:t>Prepared by Faheem for Lunar Investments — Advisory only. Not investment advice.</a:t>
+              <a:t>Prepared by Faheem for Lunar Investments, Advisory only. Not investment advice.</a:t>
             </a:r>
             <a:endParaRPr lang="en-US" sz="750" dirty="0"/>
           </a:p>
@@ -1794,7 +1794,7 @@
                 <a:ea typeface="Georgia" pitchFamily="34" charset="-122"/>
                 <a:cs typeface="Georgia" pitchFamily="34" charset="-120"/>
               </a:rPr>
-              <a:t>Investment Thesis — Jahez International (Tadawul: 6017)</a:t>
+              <a:t>Investment Thesis, Jahez International (Tadawul: 6017)</a:t>
             </a:r>
             <a:endParaRPr lang="en-US" sz="2300" dirty="0"/>
           </a:p>
@@ -2149,7 +2149,7 @@
                 <a:ea typeface="Arial" pitchFamily="34" charset="-122"/>
                 <a:cs typeface="Arial" pitchFamily="34" charset="-120"/>
               </a:rPr>
-              <a:t>FY25 EBITDA margin of 8.3% is one-off-depressed, not structurally broken — Q1-26 adj. EBITDA of SAR 43.6m stayed positive through a net-loss quarter</a:t>
+              <a:t>FY25 EBITDA margin of 8.3% is one-off-depressed, not structurally broken, Q1-26 adj. EBITDA of SAR 43.6m stayed positive through a net-loss quarter</a:t>
             </a:r>
             <a:endParaRPr lang="en-US" sz="1050" dirty="0"/>
           </a:p>
@@ -2275,7 +2275,7 @@
                 <a:ea typeface="Arial" pitchFamily="34" charset="-122"/>
                 <a:cs typeface="Arial" pitchFamily="34" charset="-120"/>
               </a:rPr>
-              <a:t>Shariah PASS, SAR 16.6m net cash, Tadawul-listed liquidity — clears Lunar's 15.0% hurdle at a 16.8% weighted return</a:t>
+              <a:t>Compliance PASS, SAR 16.6m net cash, Tadawul-listed liquidity, clears Lunar's 15.0% hurdle at a 16.8% weighted return</a:t>
             </a:r>
             <a:endParaRPr lang="en-US" sz="1050" dirty="0"/>
           </a:p>
@@ -2314,7 +2314,7 @@
                 <a:ea typeface="Arial" pitchFamily="34" charset="-122"/>
                 <a:cs typeface="Arial" pitchFamily="34" charset="-120"/>
               </a:rPr>
-              <a:t>Source: Faheem Valuation Model — see IC memo and workbook for the full source trail. Advisory only — the Investment Committee decides.</a:t>
+              <a:t>Source: Faheem Valuation Model, see IC memo and workbook for the full source trail. Advisory only, the Investment Committee decides.</a:t>
             </a:r>
             <a:endParaRPr lang="en-US" sz="800" dirty="0"/>
           </a:p>
@@ -2465,7 +2465,7 @@
                 <a:ea typeface="Arial" pitchFamily="34" charset="-122"/>
                 <a:cs typeface="Arial" pitchFamily="34" charset="-120"/>
               </a:rPr>
-              <a:t>Competitive dynamics — qualitative positioning only, no invented market-share figures</a:t>
+              <a:t>Competitive dynamics, qualitative positioning only, no invented market-share figures</a:t>
             </a:r>
             <a:endParaRPr lang="en-US" sz="1150" dirty="0"/>
           </a:p>
@@ -2570,7 +2570,7 @@
                 <a:ea typeface="Arial" pitchFamily="34" charset="-122"/>
                 <a:cs typeface="Arial" pitchFamily="34" charset="-120"/>
               </a:rPr>
-              <a:t>Incumbent KSA platform diversifying into logistics — FY25 GMV SAR 7,245.2m, 111.6m orders</a:t>
+              <a:t>Incumbent KSA platform diversifying into logistics, FY25 GMV SAR 7,245.2m, 111.6m orders</a:t>
             </a:r>
             <a:endParaRPr lang="en-US" sz="1050" dirty="0"/>
           </a:p>
@@ -2924,7 +2924,7 @@
                 <a:ea typeface="Arial" pitchFamily="34" charset="-122"/>
                 <a:cs typeface="Arial" pitchFamily="34" charset="-120"/>
               </a:rPr>
-              <a:t>Source: Industry &amp; News Pack — Saudi Quick-Commerce, p.2, p.4</a:t>
+              <a:t>Source: Industry &amp; News Pack · Saudi Quick-Commerce, p.2, p.4</a:t>
             </a:r>
             <a:endParaRPr lang="en-US" sz="800" dirty="0"/>
           </a:p>
@@ -3880,7 +3880,7 @@
                 <a:ea typeface="Georgia" pitchFamily="34" charset="-122"/>
                 <a:cs typeface="Georgia" pitchFamily="34" charset="-120"/>
               </a:rPr>
-              <a:t>Valuation — DCF vs Trading Comps</a:t>
+              <a:t>Valuation, DCF vs Trading Comps</a:t>
             </a:r>
             <a:endParaRPr lang="en-US" sz="2300" dirty="0"/>
           </a:p>
@@ -4566,7 +4566,7 @@
                 <a:ea typeface="Arial" pitchFamily="34" charset="-122"/>
                 <a:cs typeface="Arial" pitchFamily="34" charset="-120"/>
               </a:rPr>
-              <a:t>DCF target — SAR 14.36</a:t>
+              <a:t>DCF target, SAR 14.36</a:t>
             </a:r>
             <a:endParaRPr lang="en-US" sz="900" dirty="0"/>
           </a:p>
@@ -4628,7 +4628,7 @@
                 <a:ea typeface="Arial" pitchFamily="34" charset="-122"/>
                 <a:cs typeface="Arial" pitchFamily="34" charset="-120"/>
               </a:rPr>
-              <a:t>Current — SAR 12.79</a:t>
+              <a:t>Current, SAR 12.79</a:t>
             </a:r>
             <a:endParaRPr lang="en-US" sz="850" dirty="0"/>
           </a:p>
@@ -5212,7 +5212,7 @@
                 <a:ea typeface="Arial" pitchFamily="34" charset="-122"/>
                 <a:cs typeface="Arial" pitchFamily="34" charset="-120"/>
               </a:rPr>
-              <a:t>Lunar hurdle — 15.0%</a:t>
+              <a:t>Lunar hurdle, 15.0%</a:t>
             </a:r>
             <a:endParaRPr lang="en-US" sz="1000" dirty="0"/>
           </a:p>
@@ -5251,7 +5251,7 @@
                 <a:ea typeface="Arial" pitchFamily="34" charset="-122"/>
                 <a:cs typeface="Arial" pitchFamily="34" charset="-120"/>
               </a:rPr>
-              <a:t>Source: Faheem Valuation Model — Scenarios &amp; Risk tab</a:t>
+              <a:t>Source: Faheem Valuation Model, Scenarios &amp; Risk tab</a:t>
             </a:r>
             <a:endParaRPr lang="en-US" sz="800" dirty="0"/>
           </a:p>
@@ -5402,7 +5402,7 @@
                 <a:ea typeface="Arial" pitchFamily="34" charset="-122"/>
                 <a:cs typeface="Arial" pitchFamily="34" charset="-120"/>
               </a:rPr>
-              <a:t>Probability x impact, 1-5 scale — composite score 5.5 / 10</a:t>
+              <a:t>Probability x impact, 1-5 scale, composite score 5.5 / 10</a:t>
             </a:r>
             <a:endParaRPr lang="en-US" sz="1150" dirty="0"/>
           </a:p>
@@ -8426,7 +8426,7 @@
                 <a:ea typeface="Arial" pitchFamily="34" charset="-122"/>
                 <a:cs typeface="Arial" pitchFamily="34" charset="-120"/>
               </a:rPr>
-              <a:t>Source: Industry &amp; News Pack, Market Data &amp; Comparables Snapshot, Q4 2025 Earnings Results, FY2025 Earnings Call — see register for exact pages</a:t>
+              <a:t>Source: Industry &amp; News Pack, Market Data &amp; Comparables Snapshot, Q4 2025 Earnings Results, FY2025 Earnings Call, see register for exact pages</a:t>
             </a:r>
             <a:endParaRPr lang="en-US" sz="800" dirty="0"/>
           </a:p>
@@ -8538,7 +8538,7 @@
                 <a:ea typeface="Georgia" pitchFamily="34" charset="-122"/>
                 <a:cs typeface="Georgia" pitchFamily="34" charset="-120"/>
               </a:rPr>
-              <a:t>Mandate Fit — Lunar IC Charter</a:t>
+              <a:t>Mandate Fit, Lunar IC Charter</a:t>
             </a:r>
             <a:endParaRPr lang="en-US" sz="2300" dirty="0"/>
           </a:p>
@@ -9557,7 +9557,7 @@
                           <a:ea typeface="Arial" pitchFamily="34" charset="-122"/>
                           <a:cs typeface="Arial" pitchFamily="34" charset="-120"/>
                         </a:rPr>
-                        <a:t>Sized within cap — final ticket sizing is an IC decision</a:t>
+                        <a:t>Sized within cap, final ticket sizing is an IC decision</a:t>
                       </a:r>
                       <a:endParaRPr lang="en-US" sz="1000" dirty="0">
                         <a:latin typeface="Arial" charset="0"/>
@@ -9951,7 +9951,7 @@
                           <a:ea typeface="Arial" pitchFamily="34" charset="-122"/>
                           <a:cs typeface="Arial" pitchFamily="34" charset="-120"/>
                         </a:rPr>
-                        <a:t>Shariah screen</a:t>
+                        <a:t>Compliance screen</a:t>
                       </a:r>
                       <a:endParaRPr lang="en-US" sz="1000" dirty="0">
                         <a:latin typeface="Arial" charset="0"/>
@@ -10232,7 +10232,7 @@
                 <a:ea typeface="Arial" pitchFamily="34" charset="-122"/>
                 <a:cs typeface="Arial" pitchFamily="34" charset="-120"/>
               </a:rPr>
-              <a:t>* Concentration pass is directional — final ticket sizing is an Investment Committee decision, not asserted here.</a:t>
+              <a:t>* Concentration pass is directional, final ticket sizing is an Investment Committee decision, not asserted here.</a:t>
             </a:r>
             <a:endParaRPr lang="en-US" sz="850" dirty="0"/>
           </a:p>
@@ -10486,7 +10486,7 @@
                 <a:ea typeface="Arial" pitchFamily="34" charset="-122"/>
                 <a:cs typeface="Arial" pitchFamily="34" charset="-120"/>
               </a:rPr>
-              <a:t>BUY  ·  Target price SAR 14.36 (+12.3% upside)  ·  Weighted return 16.8% vs 15.0% hurdle  ·  Risk score 5.5/10  ·  Shariah PASS</a:t>
+              <a:t>BUY  ·  Target price SAR 14.36 (+12.3% upside)  ·  Weighted return 16.8% vs 15.0% hurdle  ·  Risk score 5.5/10  ·  Compliance PASS</a:t>
             </a:r>
             <a:endParaRPr lang="en-US" sz="1100" dirty="0"/>
           </a:p>
@@ -10525,7 +10525,7 @@
                 <a:ea typeface="Arial" pitchFamily="34" charset="-122"/>
                 <a:cs typeface="Arial" pitchFamily="34" charset="-120"/>
               </a:rPr>
-              <a:t>Advisory only — the investment decision rests with the committee.</a:t>
+              <a:t>Advisory only: the investment decision rests with the committee.</a:t>
             </a:r>
             <a:endParaRPr lang="en-US" sz="1500" dirty="0"/>
           </a:p>
@@ -10564,7 +10564,7 @@
                 <a:ea typeface="Arial" pitchFamily="34" charset="-122"/>
                 <a:cs typeface="Arial" pitchFamily="34" charset="-120"/>
               </a:rPr>
-              <a:t>Full source trail: IC memo and Excel valuation workbook — every figure traces to a corpus document page.</a:t>
+              <a:t>Full source trail: IC memo and Excel valuation workbook, every figure traces to a corpus document page.</a:t>
             </a:r>
             <a:endParaRPr lang="en-US" sz="800" dirty="0"/>
           </a:p>

</xml_diff>